<commit_message>
Deck 02: add 'Two halves' slide (editor-driven vs headless CI); guide slide refs updated
Co-Authored-By: Claude Fable 5.1 <noreply@anthropic.com>
</commit_message>
<xml_diff>
--- a/single_day/slides/02_unity_cli_from_scratch.pptx
+++ b/single_day/slides/02_unity_cli_from_scratch.pptx
@@ -8,6 +8,7 @@
     <p:sldId id="256" r:id="rId2"/>
     <p:sldId id="257" r:id="rId3"/>
     <p:sldId id="258" r:id="rId4"/>
+    <p:sldId id="265" r:id="rId16"/>
     <p:sldId id="259" r:id="rId5"/>
     <p:sldId id="260" r:id="rId6"/>
     <p:sldId id="261" r:id="rId7"/>
@@ -1777,6 +1778,666 @@
               <a:rPr lang="en-US" sz="850" dirty="0">
                 <a:solidFill>
                   <a:srgbClr val="8FA3B8"/>
+                </a:solidFill>
+                <a:latin typeface="Arial" pitchFamily="34" charset="0"/>
+                <a:ea typeface="Arial" pitchFamily="34" charset="-122"/>
+                <a:cs typeface="Arial" pitchFamily="34" charset="-120"/>
+              </a:rPr>
+              <a:t>Codeo · Panteon Games — Unity CLI and Pipeline (Joint Session)</a:t>
+            </a:r>
+            <a:endParaRPr lang="en-US" sz="850" dirty="0"/>
+          </a:p>
+        </p:txBody>
+      </p:sp>
+    </p:spTree>
+  </p:cSld>
+  <p:clrMapOvr>
+    <a:masterClrMapping/>
+  </p:clrMapOvr>
+</p:sld>
+</file>
+
+<file path=ppt/slides/slide10.xml><?xml version="1.0" encoding="utf-8"?>
+<p:sld xmlns:a="http://schemas.openxmlformats.org/drawingml/2006/main" xmlns:r="http://schemas.openxmlformats.org/officeDocument/2006/relationships" xmlns:p="http://schemas.openxmlformats.org/presentationml/2006/main">
+  <p:cSld name="Slide 3">
+    <p:bg>
+      <p:bgPr>
+        <a:solidFill>
+          <a:srgbClr val="FFFFFF"/>
+        </a:solidFill>
+      </p:bgPr>
+    </p:bg>
+    <p:spTree>
+      <p:nvGrpSpPr>
+        <p:cNvPr id="1" name=""/>
+        <p:cNvGrpSpPr/>
+        <p:nvPr/>
+      </p:nvGrpSpPr>
+      <p:grpSpPr>
+        <a:xfrm>
+          <a:off x="0" y="0"/>
+          <a:ext cx="0" cy="0"/>
+          <a:chOff x="0" y="0"/>
+          <a:chExt cx="0" cy="0"/>
+        </a:xfrm>
+      </p:grpSpPr>
+      <p:sp>
+        <p:nvSpPr>
+          <p:cNvPr id="2" name="Text 0"/>
+          <p:cNvSpPr txBox="1"/>
+          <p:nvPr/>
+        </p:nvSpPr>
+        <p:spPr>
+          <a:xfrm>
+            <a:off x="640080" y="475488"/>
+            <a:ext cx="10908792" cy="274320"/>
+          </a:xfrm>
+          <a:prstGeom prst="rect">
+            <a:avLst/>
+          </a:prstGeom>
+          <a:noFill/>
+          <a:ln/>
+        </p:spPr>
+        <p:txBody>
+          <a:bodyPr wrap="square" lIns="0" tIns="0" rIns="0" bIns="0" rtlCol="0" anchor="ctr"/>
+          <a:lstStyle/>
+          <a:p>
+            <a:pPr indent="0" marL="0">
+              <a:buNone/>
+            </a:pPr>
+            <a:r>
+              <a:rPr lang="en-US" sz="1100" b="1" spc="300" kern="0" dirty="0">
+                <a:solidFill>
+                  <a:srgbClr val="B08D3E"/>
+                </a:solidFill>
+                <a:latin typeface="Arial" pitchFamily="34" charset="0"/>
+                <a:ea typeface="Arial" pitchFamily="34" charset="-122"/>
+                <a:cs typeface="Arial" pitchFamily="34" charset="-120"/>
+              </a:rPr>
+              <a:t>TWO HALVES</a:t>
+            </a:r>
+            <a:endParaRPr lang="en-US" sz="1100" dirty="0"/>
+          </a:p>
+        </p:txBody>
+      </p:sp>
+      <p:sp>
+        <p:nvSpPr>
+          <p:cNvPr id="3" name="Text 1"/>
+          <p:cNvSpPr txBox="1"/>
+          <p:nvPr/>
+        </p:nvSpPr>
+        <p:spPr>
+          <a:xfrm>
+            <a:off x="640080" y="749808"/>
+            <a:ext cx="10908792" cy="685800"/>
+          </a:xfrm>
+          <a:prstGeom prst="rect">
+            <a:avLst/>
+          </a:prstGeom>
+          <a:noFill/>
+          <a:ln/>
+        </p:spPr>
+        <p:txBody>
+          <a:bodyPr wrap="square" lIns="0" tIns="0" rIns="0" bIns="0" rtlCol="0" anchor="ctr"/>
+          <a:lstStyle/>
+          <a:p>
+            <a:pPr indent="0" marL="0">
+              <a:buNone/>
+            </a:pPr>
+            <a:r>
+              <a:rPr lang="en-US" sz="2800" b="1" dirty="0">
+                <a:solidFill>
+                  <a:srgbClr val="16324F"/>
+                </a:solidFill>
+                <a:latin typeface="Arial" pitchFamily="34" charset="0"/>
+                <a:ea typeface="Arial" pitchFamily="34" charset="-122"/>
+                <a:cs typeface="Arial" pitchFamily="34" charset="-120"/>
+              </a:rPr>
+              <a:t>With an editor open — or without one</a:t>
+            </a:r>
+            <a:endParaRPr lang="en-US" sz="2800" dirty="0"/>
+          </a:p>
+        </p:txBody>
+      </p:sp>
+      <p:sp>
+        <p:nvSpPr>
+          <p:cNvPr id="4" name="Shape 2"/>
+          <p:cNvSpPr/>
+          <p:nvPr/>
+        </p:nvSpPr>
+        <p:spPr>
+          <a:xfrm>
+            <a:off x="640080" y="1691640"/>
+            <a:ext cx="3422904" cy="2286000"/>
+          </a:xfrm>
+          <a:prstGeom prst="roundRect">
+            <a:avLst>
+              <a:gd name="adj" fmla="val 3600"/>
+            </a:avLst>
+          </a:prstGeom>
+          <a:solidFill>
+            <a:srgbClr val="F4F2EE"/>
+          </a:solidFill>
+          <a:ln/>
+        </p:spPr>
+      </p:sp>
+      <p:sp>
+        <p:nvSpPr>
+          <p:cNvPr id="5" name="Shape 3"/>
+          <p:cNvSpPr/>
+          <p:nvPr/>
+        </p:nvSpPr>
+        <p:spPr>
+          <a:xfrm>
+            <a:off x="868680" y="1920240"/>
+            <a:ext cx="457200" cy="457200"/>
+          </a:xfrm>
+          <a:prstGeom prst="ellipse">
+            <a:avLst/>
+          </a:prstGeom>
+          <a:solidFill>
+            <a:srgbClr val="16324F"/>
+          </a:solidFill>
+          <a:ln/>
+        </p:spPr>
+      </p:sp>
+      <p:pic>
+        <p:nvPicPr>
+          <p:cNvPr id="6" name="Image 0" descr="preencoded.png">    </p:cNvPr>
+          <p:cNvPicPr>
+            <a:picLocks noChangeAspect="1"/>
+          </p:cNvPicPr>
+          <p:nvPr/>
+        </p:nvPicPr>
+        <p:blipFill>
+          <a:blip r:embed="rId1"/>
+          <a:stretch>
+            <a:fillRect/>
+          </a:stretch>
+        </p:blipFill>
+        <p:spPr>
+          <a:xfrm>
+            <a:off x="987552" y="2039112"/>
+            <a:ext cx="219456" cy="219456"/>
+          </a:xfrm>
+          <a:prstGeom prst="rect">
+            <a:avLst/>
+          </a:prstGeom>
+        </p:spPr>
+      </p:pic>
+      <p:sp>
+        <p:nvSpPr>
+          <p:cNvPr id="7" name="Text 4"/>
+          <p:cNvSpPr txBox="1"/>
+          <p:nvPr/>
+        </p:nvSpPr>
+        <p:spPr>
+          <a:xfrm>
+            <a:off x="1463040" y="1892808"/>
+            <a:ext cx="2417064" cy="548640"/>
+          </a:xfrm>
+          <a:prstGeom prst="rect">
+            <a:avLst/>
+          </a:prstGeom>
+          <a:noFill/>
+          <a:ln/>
+        </p:spPr>
+        <p:txBody>
+          <a:bodyPr wrap="square" lIns="0" tIns="0" rIns="0" bIns="0" rtlCol="0" anchor="t"/>
+          <a:lstStyle/>
+          <a:p>
+            <a:pPr indent="0" marL="0">
+              <a:lnSpc>
+                <a:spcPct val="100000"/>
+              </a:lnSpc>
+              <a:buNone/>
+            </a:pPr>
+            <a:r>
+              <a:rPr lang="en-US" sz="1450" b="1" dirty="0">
+                <a:solidFill>
+                  <a:srgbClr val="16324F"/>
+                </a:solidFill>
+                <a:latin typeface="Arial" pitchFamily="34" charset="0"/>
+                <a:ea typeface="Arial" pitchFamily="34" charset="-122"/>
+                <a:cs typeface="Arial" pitchFamily="34" charset="-120"/>
+              </a:rPr>
+              <a:t>Without an editor</a:t>
+            </a:r>
+            <a:endParaRPr lang="en-US" sz="1450" dirty="0"/>
+          </a:p>
+        </p:txBody>
+      </p:sp>
+      <p:sp>
+        <p:nvSpPr>
+          <p:cNvPr id="8" name="Text 5"/>
+          <p:cNvSpPr txBox="1"/>
+          <p:nvPr/>
+        </p:nvSpPr>
+        <p:spPr>
+          <a:xfrm>
+            <a:off x="868680" y="2532888"/>
+            <a:ext cx="2965704" cy="1280160"/>
+          </a:xfrm>
+          <a:prstGeom prst="rect">
+            <a:avLst/>
+          </a:prstGeom>
+          <a:noFill/>
+          <a:ln/>
+        </p:spPr>
+        <p:txBody>
+          <a:bodyPr wrap="square" lIns="0" tIns="0" rIns="0" bIns="0" rtlCol="0" anchor="ctr"/>
+          <a:lstStyle/>
+          <a:p>
+            <a:pPr indent="0" marL="0">
+              <a:lnSpc>
+                <a:spcPct val="110000"/>
+              </a:lnSpc>
+              <a:buNone/>
+            </a:pPr>
+            <a:r>
+              <a:rPr lang="en-US" sz="1150" dirty="0">
+                <a:solidFill>
+                  <a:srgbClr val="3A3F46"/>
+                </a:solidFill>
+                <a:latin typeface="Arial" pitchFamily="34" charset="0"/>
+                <a:ea typeface="Arial" pitchFamily="34" charset="-122"/>
+                <a:cs typeface="Arial" pitchFamily="34" charset="-120"/>
+              </a:rPr>
+              <a:t>unity install · projects · auth · license — and the CI trio unity build, test, run: they start their own headless editor in batch mode and return an exit code.</a:t>
+            </a:r>
+            <a:endParaRPr lang="en-US" sz="1150" dirty="0"/>
+          </a:p>
+        </p:txBody>
+      </p:sp>
+      <p:sp>
+        <p:nvSpPr>
+          <p:cNvPr id="9" name="Shape 6"/>
+          <p:cNvSpPr/>
+          <p:nvPr/>
+        </p:nvSpPr>
+        <p:spPr>
+          <a:xfrm>
+            <a:off x="4383024" y="1691640"/>
+            <a:ext cx="3422904" cy="2286000"/>
+          </a:xfrm>
+          <a:prstGeom prst="roundRect">
+            <a:avLst>
+              <a:gd name="adj" fmla="val 3600"/>
+            </a:avLst>
+          </a:prstGeom>
+          <a:solidFill>
+            <a:srgbClr val="F4F2EE"/>
+          </a:solidFill>
+          <a:ln/>
+        </p:spPr>
+      </p:sp>
+      <p:sp>
+        <p:nvSpPr>
+          <p:cNvPr id="10" name="Shape 7"/>
+          <p:cNvSpPr/>
+          <p:nvPr/>
+        </p:nvSpPr>
+        <p:spPr>
+          <a:xfrm>
+            <a:off x="4611624" y="1920240"/>
+            <a:ext cx="457200" cy="457200"/>
+          </a:xfrm>
+          <a:prstGeom prst="ellipse">
+            <a:avLst/>
+          </a:prstGeom>
+          <a:solidFill>
+            <a:srgbClr val="16324F"/>
+          </a:solidFill>
+          <a:ln/>
+        </p:spPr>
+      </p:sp>
+      <p:pic>
+        <p:nvPicPr>
+          <p:cNvPr id="11" name="Image 1" descr="preencoded.png">    </p:cNvPr>
+          <p:cNvPicPr>
+            <a:picLocks noChangeAspect="1"/>
+          </p:cNvPicPr>
+          <p:nvPr/>
+        </p:nvPicPr>
+        <p:blipFill>
+          <a:blip r:embed="rId2"/>
+          <a:stretch>
+            <a:fillRect/>
+          </a:stretch>
+        </p:blipFill>
+        <p:spPr>
+          <a:xfrm>
+            <a:off x="4730496" y="2039112"/>
+            <a:ext cx="219456" cy="219456"/>
+          </a:xfrm>
+          <a:prstGeom prst="rect">
+            <a:avLst/>
+          </a:prstGeom>
+        </p:spPr>
+      </p:pic>
+      <p:sp>
+        <p:nvSpPr>
+          <p:cNvPr id="12" name="Text 8"/>
+          <p:cNvSpPr txBox="1"/>
+          <p:nvPr/>
+        </p:nvSpPr>
+        <p:spPr>
+          <a:xfrm>
+            <a:off x="5205984" y="1892808"/>
+            <a:ext cx="2417064" cy="548640"/>
+          </a:xfrm>
+          <a:prstGeom prst="rect">
+            <a:avLst/>
+          </a:prstGeom>
+          <a:noFill/>
+          <a:ln/>
+        </p:spPr>
+        <p:txBody>
+          <a:bodyPr wrap="square" lIns="0" tIns="0" rIns="0" bIns="0" rtlCol="0" anchor="t"/>
+          <a:lstStyle/>
+          <a:p>
+            <a:pPr indent="0" marL="0">
+              <a:lnSpc>
+                <a:spcPct val="100000"/>
+              </a:lnSpc>
+              <a:buNone/>
+            </a:pPr>
+            <a:r>
+              <a:rPr lang="en-US" sz="1450" b="1" dirty="0">
+                <a:solidFill>
+                  <a:srgbClr val="16324F"/>
+                </a:solidFill>
+                <a:latin typeface="Arial" pitchFamily="34" charset="0"/>
+                <a:ea typeface="Arial" pitchFamily="34" charset="-122"/>
+                <a:cs typeface="Arial" pitchFamily="34" charset="-120"/>
+              </a:rPr>
+              <a:t>With a running editor</a:t>
+            </a:r>
+            <a:endParaRPr lang="en-US" sz="1450" dirty="0"/>
+          </a:p>
+        </p:txBody>
+      </p:sp>
+      <p:sp>
+        <p:nvSpPr>
+          <p:cNvPr id="13" name="Text 9"/>
+          <p:cNvSpPr txBox="1"/>
+          <p:nvPr/>
+        </p:nvSpPr>
+        <p:spPr>
+          <a:xfrm>
+            <a:off x="4611624" y="2532888"/>
+            <a:ext cx="2965704" cy="1280160"/>
+          </a:xfrm>
+          <a:prstGeom prst="rect">
+            <a:avLst/>
+          </a:prstGeom>
+          <a:noFill/>
+          <a:ln/>
+        </p:spPr>
+        <p:txBody>
+          <a:bodyPr wrap="square" lIns="0" tIns="0" rIns="0" bIns="0" rtlCol="0" anchor="ctr"/>
+          <a:lstStyle/>
+          <a:p>
+            <a:pPr indent="0" marL="0">
+              <a:lnSpc>
+                <a:spcPct val="110000"/>
+              </a:lnSpc>
+              <a:buNone/>
+            </a:pPr>
+            <a:r>
+              <a:rPr lang="en-US" sz="1150" dirty="0">
+                <a:solidFill>
+                  <a:srgbClr val="3A3F46"/>
+                </a:solidFill>
+                <a:latin typeface="Arial" pitchFamily="34" charset="0"/>
+                <a:ea typeface="Arial" pitchFamily="34" charset="-122"/>
+                <a:cs typeface="Arial" pitchFamily="34" charset="-120"/>
+              </a:rPr>
+              <a:t>unity status and unity command — eval, open_scene, attach_script, the live build, your own level_lint. A remote control for an editor with com.unity.pipeline loaded; no editor, no connection.</a:t>
+            </a:r>
+            <a:endParaRPr lang="en-US" sz="1150" dirty="0"/>
+          </a:p>
+        </p:txBody>
+      </p:sp>
+      <p:sp>
+        <p:nvSpPr>
+          <p:cNvPr id="14" name="Shape 10"/>
+          <p:cNvSpPr/>
+          <p:nvPr/>
+        </p:nvSpPr>
+        <p:spPr>
+          <a:xfrm>
+            <a:off x="8125968" y="1691640"/>
+            <a:ext cx="3422904" cy="2286000"/>
+          </a:xfrm>
+          <a:prstGeom prst="roundRect">
+            <a:avLst>
+              <a:gd name="adj" fmla="val 3600"/>
+            </a:avLst>
+          </a:prstGeom>
+          <a:solidFill>
+            <a:srgbClr val="F4F2EE"/>
+          </a:solidFill>
+          <a:ln/>
+        </p:spPr>
+      </p:sp>
+      <p:sp>
+        <p:nvSpPr>
+          <p:cNvPr id="15" name="Shape 11"/>
+          <p:cNvSpPr/>
+          <p:nvPr/>
+        </p:nvSpPr>
+        <p:spPr>
+          <a:xfrm>
+            <a:off x="8354568" y="1920240"/>
+            <a:ext cx="457200" cy="457200"/>
+          </a:xfrm>
+          <a:prstGeom prst="ellipse">
+            <a:avLst/>
+          </a:prstGeom>
+          <a:solidFill>
+            <a:srgbClr val="16324F"/>
+          </a:solidFill>
+          <a:ln/>
+        </p:spPr>
+      </p:sp>
+      <p:pic>
+        <p:nvPicPr>
+          <p:cNvPr id="16" name="Image 2" descr="preencoded.png">    </p:cNvPr>
+          <p:cNvPicPr>
+            <a:picLocks noChangeAspect="1"/>
+          </p:cNvPicPr>
+          <p:nvPr/>
+        </p:nvPicPr>
+        <p:blipFill>
+          <a:blip r:embed="rId3"/>
+          <a:stretch>
+            <a:fillRect/>
+          </a:stretch>
+        </p:blipFill>
+        <p:spPr>
+          <a:xfrm>
+            <a:off x="8473440" y="2039112"/>
+            <a:ext cx="219456" cy="219456"/>
+          </a:xfrm>
+          <a:prstGeom prst="rect">
+            <a:avLst/>
+          </a:prstGeom>
+        </p:spPr>
+      </p:pic>
+      <p:sp>
+        <p:nvSpPr>
+          <p:cNvPr id="17" name="Text 12"/>
+          <p:cNvSpPr txBox="1"/>
+          <p:nvPr/>
+        </p:nvSpPr>
+        <p:spPr>
+          <a:xfrm>
+            <a:off x="8948928" y="1892808"/>
+            <a:ext cx="2417064" cy="548640"/>
+          </a:xfrm>
+          <a:prstGeom prst="rect">
+            <a:avLst/>
+          </a:prstGeom>
+          <a:noFill/>
+          <a:ln/>
+        </p:spPr>
+        <p:txBody>
+          <a:bodyPr wrap="square" lIns="0" tIns="0" rIns="0" bIns="0" rtlCol="0" anchor="t"/>
+          <a:lstStyle/>
+          <a:p>
+            <a:pPr indent="0" marL="0">
+              <a:lnSpc>
+                <a:spcPct val="100000"/>
+              </a:lnSpc>
+              <a:buNone/>
+            </a:pPr>
+            <a:r>
+              <a:rPr lang="en-US" sz="1450" b="1" dirty="0">
+                <a:solidFill>
+                  <a:srgbClr val="16324F"/>
+                </a:solidFill>
+                <a:latin typeface="Arial" pitchFamily="34" charset="0"/>
+                <a:ea typeface="Arial" pitchFamily="34" charset="-122"/>
+                <a:cs typeface="Arial" pitchFamily="34" charset="-120"/>
+              </a:rPr>
+              <a:t>Where today lives</a:t>
+            </a:r>
+            <a:endParaRPr lang="en-US" sz="1450" dirty="0"/>
+          </a:p>
+        </p:txBody>
+      </p:sp>
+      <p:sp>
+        <p:nvSpPr>
+          <p:cNvPr id="18" name="Text 13"/>
+          <p:cNvSpPr txBox="1"/>
+          <p:nvPr/>
+        </p:nvSpPr>
+        <p:spPr>
+          <a:xfrm>
+            <a:off x="8354568" y="2532888"/>
+            <a:ext cx="2965704" cy="1280160"/>
+          </a:xfrm>
+          <a:prstGeom prst="rect">
+            <a:avLst/>
+          </a:prstGeom>
+          <a:noFill/>
+          <a:ln/>
+        </p:spPr>
+        <p:txBody>
+          <a:bodyPr wrap="square" lIns="0" tIns="0" rIns="0" bIns="0" rtlCol="0" anchor="ctr"/>
+          <a:lstStyle/>
+          <a:p>
+            <a:pPr indent="0" marL="0">
+              <a:lnSpc>
+                <a:spcPct val="110000"/>
+              </a:lnSpc>
+              <a:buNone/>
+            </a:pPr>
+            <a:r>
+              <a:rPr lang="en-US" sz="1150" dirty="0">
+                <a:solidFill>
+                  <a:srgbClr val="3A3F46"/>
+                </a:solidFill>
+                <a:latin typeface="Arial" pitchFamily="34" charset="0"/>
+                <a:ea typeface="Arial" pitchFamily="34" charset="-122"/>
+                <a:cs typeface="Arial" pitchFamily="34" charset="-120"/>
+              </a:rPr>
+              <a:t>Almost entirely in the second half — every proof today talks to an open editor. Ex09 shows both: the live build in the lab, the headless CI build at the closing.</a:t>
+            </a:r>
+            <a:endParaRPr lang="en-US" sz="1150" dirty="0"/>
+          </a:p>
+        </p:txBody>
+      </p:sp>
+      <p:sp>
+        <p:nvSpPr>
+          <p:cNvPr id="19" name="Shape 14"/>
+          <p:cNvSpPr/>
+          <p:nvPr/>
+        </p:nvSpPr>
+        <p:spPr>
+          <a:xfrm>
+            <a:off x="640080" y="5943600"/>
+            <a:ext cx="10908792" cy="502920"/>
+          </a:xfrm>
+          <a:prstGeom prst="roundRect">
+            <a:avLst>
+              <a:gd name="adj" fmla="val 14545"/>
+            </a:avLst>
+          </a:prstGeom>
+          <a:solidFill>
+            <a:srgbClr val="F1EADB"/>
+          </a:solidFill>
+          <a:ln/>
+        </p:spPr>
+      </p:sp>
+      <p:sp>
+        <p:nvSpPr>
+          <p:cNvPr id="20" name="Text 15"/>
+          <p:cNvSpPr txBox="1"/>
+          <p:nvPr/>
+        </p:nvSpPr>
+        <p:spPr>
+          <a:xfrm>
+            <a:off x="868680" y="5943600"/>
+            <a:ext cx="10451592" cy="502920"/>
+          </a:xfrm>
+          <a:prstGeom prst="rect">
+            <a:avLst/>
+          </a:prstGeom>
+          <a:noFill/>
+          <a:ln/>
+        </p:spPr>
+        <p:txBody>
+          <a:bodyPr wrap="square" lIns="0" tIns="0" rIns="0" bIns="0" rtlCol="0" anchor="ctr"/>
+          <a:lstStyle/>
+          <a:p>
+            <a:pPr indent="0" marL="0">
+              <a:buNone/>
+            </a:pPr>
+            <a:r>
+              <a:rPr lang="en-US" sz="1200" i="1" dirty="0">
+                <a:solidFill>
+                  <a:srgbClr val="16324F"/>
+                </a:solidFill>
+                <a:latin typeface="Arial" pitchFamily="34" charset="0"/>
+                <a:ea typeface="Arial" pitchFamily="34" charset="-122"/>
+                <a:cs typeface="Arial" pitchFamily="34" charset="-120"/>
+              </a:rPr>
+              <a:t>Safe Mode (a compile error on open) breaks the connection exactly like a missing editor — that is why the day starts with unity status → ready.</a:t>
+            </a:r>
+            <a:endParaRPr lang="en-US" sz="1200" dirty="0"/>
+          </a:p>
+        </p:txBody>
+      </p:sp>
+      <p:sp>
+        <p:nvSpPr>
+          <p:cNvPr id="21" name="Text 16"/>
+          <p:cNvSpPr txBox="1"/>
+          <p:nvPr/>
+        </p:nvSpPr>
+        <p:spPr>
+          <a:xfrm>
+            <a:off x="640080" y="6455664"/>
+            <a:ext cx="10908792" cy="274320"/>
+          </a:xfrm>
+          <a:prstGeom prst="rect">
+            <a:avLst/>
+          </a:prstGeom>
+          <a:noFill/>
+          <a:ln/>
+        </p:spPr>
+        <p:txBody>
+          <a:bodyPr wrap="square" lIns="0" tIns="0" rIns="0" bIns="0" rtlCol="0" anchor="ctr"/>
+          <a:lstStyle/>
+          <a:p>
+            <a:pPr algn="ctr" indent="0" marL="0">
+              <a:buNone/>
+            </a:pPr>
+            <a:r>
+              <a:rPr lang="en-US" sz="850" dirty="0">
+                <a:solidFill>
+                  <a:srgbClr val="9AA0A6"/>
                 </a:solidFill>
                 <a:latin typeface="Arial" pitchFamily="34" charset="0"/>
                 <a:ea typeface="Arial" pitchFamily="34" charset="-122"/>

</xml_diff>